<commit_message>
Finalize cash-flow reconciliation and working-capital recommendations
</commit_message>
<xml_diff>
--- a/reports/Dixon_Recommendation_Deck.pptx
+++ b/reports/Dixon_Recommendation_Deck.pptx
@@ -2,18 +2,18 @@
 <file path=ppt/presentation.xml><?xml version="1.0" encoding="utf-8"?>
 <p:presentation xmlns:p="http://schemas.openxmlformats.org/presentationml/2006/main">
   <p:sldMasterIdLst>
-    <p:sldMasterId xmlns:r="http://schemas.openxmlformats.org/officeDocument/2006/relationships" id="2147483648" r:id="R0be5e1eb539343dc"/>
+    <p:sldMasterId xmlns:r="http://schemas.openxmlformats.org/officeDocument/2006/relationships" id="2147483648" r:id="R5617789d23554079"/>
   </p:sldMasterIdLst>
   <p:notesMasterIdLst>
-    <p:notesMasterId xmlns:r="http://schemas.openxmlformats.org/officeDocument/2006/relationships" r:id="R251bf0e295bc42be"/>
+    <p:notesMasterId xmlns:r="http://schemas.openxmlformats.org/officeDocument/2006/relationships" r:id="Ra9d90b67a16543c9"/>
   </p:notesMasterIdLst>
   <p:sldIdLst>
-    <p:sldId xmlns:r="http://schemas.openxmlformats.org/officeDocument/2006/relationships" id="256" r:id="Rc0d5c1c007a64c0d"/>
-    <p:sldId xmlns:r="http://schemas.openxmlformats.org/officeDocument/2006/relationships" id="257" r:id="R2c66574fb8cb47d6"/>
-    <p:sldId xmlns:r="http://schemas.openxmlformats.org/officeDocument/2006/relationships" id="258" r:id="Rf8ef1d44afb2420c"/>
-    <p:sldId xmlns:r="http://schemas.openxmlformats.org/officeDocument/2006/relationships" id="259" r:id="R80af4d71a55f4102"/>
-    <p:sldId xmlns:r="http://schemas.openxmlformats.org/officeDocument/2006/relationships" id="260" r:id="R80ccc3c644d344e4"/>
-    <p:sldId xmlns:r="http://schemas.openxmlformats.org/officeDocument/2006/relationships" id="261" r:id="Rd7cad6c35b70452f"/>
+    <p:sldId xmlns:r="http://schemas.openxmlformats.org/officeDocument/2006/relationships" id="256" r:id="R55cfd68e9f3c4062"/>
+    <p:sldId xmlns:r="http://schemas.openxmlformats.org/officeDocument/2006/relationships" id="257" r:id="R318fb7528fb24b1b"/>
+    <p:sldId xmlns:r="http://schemas.openxmlformats.org/officeDocument/2006/relationships" id="258" r:id="Rbad8b78857b843a1"/>
+    <p:sldId xmlns:r="http://schemas.openxmlformats.org/officeDocument/2006/relationships" id="259" r:id="Re2a42c37b4cd4379"/>
+    <p:sldId xmlns:r="http://schemas.openxmlformats.org/officeDocument/2006/relationships" id="260" r:id="R8ee62e12dfa342ea"/>
+    <p:sldId xmlns:r="http://schemas.openxmlformats.org/officeDocument/2006/relationships" id="261" r:id="Rd2bc2eeeefe14431"/>
   </p:sldIdLst>
   <p:sldSz cx="12192000" cy="6858000"/>
   <p:notesSz cx="6858000" cy="9144000"/>
@@ -1056,6 +1056,7 @@
                 <a:spcPts val="0"/>
               </a:spcAft>
               <a:buNone/>
+              <a:defRPr/>
             </a:lvl1pPr>
             <a:lvl2pPr marL="0" indent="0">
               <a:lnSpc>
@@ -1068,6 +1069,7 @@
                 <a:spcPts val="0"/>
               </a:spcAft>
               <a:buNone/>
+              <a:defRPr/>
             </a:lvl2pPr>
             <a:lvl3pPr marL="0" indent="0">
               <a:lnSpc>
@@ -1080,6 +1082,7 @@
                 <a:spcPts val="0"/>
               </a:spcAft>
               <a:buNone/>
+              <a:defRPr/>
             </a:lvl3pPr>
             <a:lvl4pPr marL="0" indent="0">
               <a:lnSpc>
@@ -1092,6 +1095,7 @@
                 <a:spcPts val="0"/>
               </a:spcAft>
               <a:buNone/>
+              <a:defRPr/>
             </a:lvl4pPr>
             <a:lvl5pPr marL="0" indent="0">
               <a:lnSpc>
@@ -1104,6 +1108,7 @@
                 <a:spcPts val="0"/>
               </a:spcAft>
               <a:buNone/>
+              <a:defRPr/>
             </a:lvl5pPr>
             <a:lvl6pPr marL="0" indent="0">
               <a:lnSpc>
@@ -1116,6 +1121,7 @@
                 <a:spcPts val="0"/>
               </a:spcAft>
               <a:buNone/>
+              <a:defRPr/>
             </a:lvl6pPr>
             <a:lvl7pPr marL="0" indent="0">
               <a:lnSpc>
@@ -1128,6 +1134,7 @@
                 <a:spcPts val="0"/>
               </a:spcAft>
               <a:buNone/>
+              <a:defRPr/>
             </a:lvl7pPr>
             <a:lvl8pPr marL="0" indent="0">
               <a:lnSpc>
@@ -1140,6 +1147,7 @@
                 <a:spcPts val="0"/>
               </a:spcAft>
               <a:buNone/>
+              <a:defRPr/>
             </a:lvl8pPr>
             <a:lvl9pPr marL="0" indent="0">
               <a:lnSpc>
@@ -1152,6 +1160,7 @@
                 <a:spcPts val="0"/>
               </a:spcAft>
               <a:buNone/>
+              <a:defRPr/>
             </a:lvl9pPr>
           </a:lstStyle>
           <a:p xmlns:a="http://schemas.openxmlformats.org/drawingml/2006/main"/>
@@ -1203,6 +1212,7 @@
                 <a:spcPts val="0"/>
               </a:spcAft>
               <a:buNone/>
+              <a:defRPr/>
             </a:lvl1pPr>
             <a:lvl2pPr marL="0" indent="0">
               <a:lnSpc>
@@ -1215,6 +1225,7 @@
                 <a:spcPts val="0"/>
               </a:spcAft>
               <a:buNone/>
+              <a:defRPr/>
             </a:lvl2pPr>
             <a:lvl3pPr marL="0" indent="0">
               <a:lnSpc>
@@ -1227,6 +1238,7 @@
                 <a:spcPts val="0"/>
               </a:spcAft>
               <a:buNone/>
+              <a:defRPr/>
             </a:lvl3pPr>
             <a:lvl4pPr marL="0" indent="0">
               <a:lnSpc>
@@ -1239,6 +1251,7 @@
                 <a:spcPts val="0"/>
               </a:spcAft>
               <a:buNone/>
+              <a:defRPr/>
             </a:lvl4pPr>
             <a:lvl5pPr marL="0" indent="0">
               <a:lnSpc>
@@ -1251,6 +1264,7 @@
                 <a:spcPts val="0"/>
               </a:spcAft>
               <a:buNone/>
+              <a:defRPr/>
             </a:lvl5pPr>
             <a:lvl6pPr marL="0" indent="0">
               <a:lnSpc>
@@ -1263,6 +1277,7 @@
                 <a:spcPts val="0"/>
               </a:spcAft>
               <a:buNone/>
+              <a:defRPr/>
             </a:lvl6pPr>
             <a:lvl7pPr marL="0" indent="0">
               <a:lnSpc>
@@ -1275,6 +1290,7 @@
                 <a:spcPts val="0"/>
               </a:spcAft>
               <a:buNone/>
+              <a:defRPr/>
             </a:lvl7pPr>
             <a:lvl8pPr marL="0" indent="0">
               <a:lnSpc>
@@ -1287,6 +1303,7 @@
                 <a:spcPts val="0"/>
               </a:spcAft>
               <a:buNone/>
+              <a:defRPr/>
             </a:lvl8pPr>
             <a:lvl9pPr marL="0" indent="0">
               <a:lnSpc>
@@ -1299,6 +1316,7 @@
                 <a:spcPts val="0"/>
               </a:spcAft>
               <a:buNone/>
+              <a:defRPr/>
             </a:lvl9pPr>
           </a:lstStyle>
           <a:p xmlns:a="http://schemas.openxmlformats.org/drawingml/2006/main"/>
@@ -1398,6 +1416,7 @@
                 <a:spcPts val="0"/>
               </a:spcAft>
               <a:buNone/>
+              <a:defRPr/>
             </a:lvl1pPr>
             <a:lvl2pPr marL="0" indent="0">
               <a:lnSpc>
@@ -1410,6 +1429,7 @@
                 <a:spcPts val="0"/>
               </a:spcAft>
               <a:buNone/>
+              <a:defRPr/>
             </a:lvl2pPr>
             <a:lvl3pPr marL="0" indent="0">
               <a:lnSpc>
@@ -1422,6 +1442,7 @@
                 <a:spcPts val="0"/>
               </a:spcAft>
               <a:buNone/>
+              <a:defRPr/>
             </a:lvl3pPr>
             <a:lvl4pPr marL="0" indent="0">
               <a:lnSpc>
@@ -1434,6 +1455,7 @@
                 <a:spcPts val="0"/>
               </a:spcAft>
               <a:buNone/>
+              <a:defRPr/>
             </a:lvl4pPr>
             <a:lvl5pPr marL="0" indent="0">
               <a:lnSpc>
@@ -1446,6 +1468,7 @@
                 <a:spcPts val="0"/>
               </a:spcAft>
               <a:buNone/>
+              <a:defRPr/>
             </a:lvl5pPr>
             <a:lvl6pPr marL="0" indent="0">
               <a:lnSpc>
@@ -1458,6 +1481,7 @@
                 <a:spcPts val="0"/>
               </a:spcAft>
               <a:buNone/>
+              <a:defRPr/>
             </a:lvl6pPr>
             <a:lvl7pPr marL="0" indent="0">
               <a:lnSpc>
@@ -1470,6 +1494,7 @@
                 <a:spcPts val="0"/>
               </a:spcAft>
               <a:buNone/>
+              <a:defRPr/>
             </a:lvl7pPr>
             <a:lvl8pPr marL="0" indent="0">
               <a:lnSpc>
@@ -1482,6 +1507,7 @@
                 <a:spcPts val="0"/>
               </a:spcAft>
               <a:buNone/>
+              <a:defRPr/>
             </a:lvl8pPr>
             <a:lvl9pPr marL="0" indent="0">
               <a:lnSpc>
@@ -1494,6 +1520,7 @@
                 <a:spcPts val="0"/>
               </a:spcAft>
               <a:buNone/>
+              <a:defRPr/>
             </a:lvl9pPr>
           </a:lstStyle>
           <a:p xmlns:a="http://schemas.openxmlformats.org/drawingml/2006/main"/>
@@ -1593,6 +1620,7 @@
                 <a:spcPts val="0"/>
               </a:spcAft>
               <a:buNone/>
+              <a:defRPr/>
             </a:lvl1pPr>
             <a:lvl2pPr marL="0" indent="0">
               <a:lnSpc>
@@ -1605,6 +1633,7 @@
                 <a:spcPts val="0"/>
               </a:spcAft>
               <a:buNone/>
+              <a:defRPr/>
             </a:lvl2pPr>
             <a:lvl3pPr marL="0" indent="0">
               <a:lnSpc>
@@ -1617,6 +1646,7 @@
                 <a:spcPts val="0"/>
               </a:spcAft>
               <a:buNone/>
+              <a:defRPr/>
             </a:lvl3pPr>
             <a:lvl4pPr marL="0" indent="0">
               <a:lnSpc>
@@ -1629,6 +1659,7 @@
                 <a:spcPts val="0"/>
               </a:spcAft>
               <a:buNone/>
+              <a:defRPr/>
             </a:lvl4pPr>
             <a:lvl5pPr marL="0" indent="0">
               <a:lnSpc>
@@ -1641,6 +1672,7 @@
                 <a:spcPts val="0"/>
               </a:spcAft>
               <a:buNone/>
+              <a:defRPr/>
             </a:lvl5pPr>
             <a:lvl6pPr marL="0" indent="0">
               <a:lnSpc>
@@ -1653,6 +1685,7 @@
                 <a:spcPts val="0"/>
               </a:spcAft>
               <a:buNone/>
+              <a:defRPr/>
             </a:lvl6pPr>
             <a:lvl7pPr marL="0" indent="0">
               <a:lnSpc>
@@ -1665,6 +1698,7 @@
                 <a:spcPts val="0"/>
               </a:spcAft>
               <a:buNone/>
+              <a:defRPr/>
             </a:lvl7pPr>
             <a:lvl8pPr marL="0" indent="0">
               <a:lnSpc>
@@ -1677,6 +1711,7 @@
                 <a:spcPts val="0"/>
               </a:spcAft>
               <a:buNone/>
+              <a:defRPr/>
             </a:lvl8pPr>
             <a:lvl9pPr marL="0" indent="0">
               <a:lnSpc>
@@ -1689,6 +1724,7 @@
                 <a:spcPts val="0"/>
               </a:spcAft>
               <a:buNone/>
+              <a:defRPr/>
             </a:lvl9pPr>
           </a:lstStyle>
           <a:p xmlns:a="http://schemas.openxmlformats.org/drawingml/2006/main"/>
@@ -1740,6 +1776,7 @@
                 <a:spcPts val="1200"/>
               </a:spcAft>
               <a:buChar char="•"/>
+              <a:defRPr/>
             </a:lvl1pPr>
             <a:lvl2pPr marL="533400" indent="-228600">
               <a:lnSpc>
@@ -1752,6 +1789,7 @@
                 <a:spcPts val="1200"/>
               </a:spcAft>
               <a:buChar char="•"/>
+              <a:defRPr/>
             </a:lvl2pPr>
             <a:lvl3pPr marL="838200" indent="-228600">
               <a:lnSpc>
@@ -1764,6 +1802,7 @@
                 <a:spcPts val="1200"/>
               </a:spcAft>
               <a:buChar char="•"/>
+              <a:defRPr/>
             </a:lvl3pPr>
             <a:lvl4pPr marL="1143000" indent="-228600">
               <a:lnSpc>
@@ -1776,6 +1815,7 @@
                 <a:spcPts val="1200"/>
               </a:spcAft>
               <a:buChar char="•"/>
+              <a:defRPr/>
             </a:lvl4pPr>
             <a:lvl5pPr marL="1447800" indent="-228600">
               <a:lnSpc>
@@ -1788,6 +1828,7 @@
                 <a:spcPts val="1200"/>
               </a:spcAft>
               <a:buChar char="•"/>
+              <a:defRPr/>
             </a:lvl5pPr>
             <a:lvl6pPr marL="1752600" indent="-228600">
               <a:lnSpc>
@@ -1800,6 +1841,7 @@
                 <a:spcPts val="1200"/>
               </a:spcAft>
               <a:buChar char="•"/>
+              <a:defRPr/>
             </a:lvl6pPr>
             <a:lvl7pPr marL="2057400" indent="-228600">
               <a:lnSpc>
@@ -1812,6 +1854,7 @@
                 <a:spcPts val="1200"/>
               </a:spcAft>
               <a:buChar char="•"/>
+              <a:defRPr/>
             </a:lvl7pPr>
             <a:lvl8pPr marL="2362200" indent="-228600">
               <a:lnSpc>
@@ -1824,6 +1867,7 @@
                 <a:spcPts val="1200"/>
               </a:spcAft>
               <a:buChar char="•"/>
+              <a:defRPr/>
             </a:lvl8pPr>
             <a:lvl9pPr marL="2667000" indent="-228600">
               <a:lnSpc>
@@ -1836,6 +1880,7 @@
                 <a:spcPts val="1200"/>
               </a:spcAft>
               <a:buChar char="•"/>
+              <a:defRPr/>
             </a:lvl9pPr>
           </a:lstStyle>
           <a:p xmlns:a="http://schemas.openxmlformats.org/drawingml/2006/main"/>
@@ -1935,6 +1980,7 @@
                 <a:spcPts val="0"/>
               </a:spcAft>
               <a:buNone/>
+              <a:defRPr/>
             </a:lvl1pPr>
             <a:lvl2pPr marL="0" indent="0">
               <a:lnSpc>
@@ -1947,6 +1993,7 @@
                 <a:spcPts val="0"/>
               </a:spcAft>
               <a:buNone/>
+              <a:defRPr/>
             </a:lvl2pPr>
             <a:lvl3pPr marL="0" indent="0">
               <a:lnSpc>
@@ -1959,6 +2006,7 @@
                 <a:spcPts val="0"/>
               </a:spcAft>
               <a:buNone/>
+              <a:defRPr/>
             </a:lvl3pPr>
             <a:lvl4pPr marL="0" indent="0">
               <a:lnSpc>
@@ -1971,6 +2019,7 @@
                 <a:spcPts val="0"/>
               </a:spcAft>
               <a:buNone/>
+              <a:defRPr/>
             </a:lvl4pPr>
             <a:lvl5pPr marL="0" indent="0">
               <a:lnSpc>
@@ -1983,6 +2032,7 @@
                 <a:spcPts val="0"/>
               </a:spcAft>
               <a:buNone/>
+              <a:defRPr/>
             </a:lvl5pPr>
             <a:lvl6pPr marL="0" indent="0">
               <a:lnSpc>
@@ -1995,6 +2045,7 @@
                 <a:spcPts val="0"/>
               </a:spcAft>
               <a:buNone/>
+              <a:defRPr/>
             </a:lvl6pPr>
             <a:lvl7pPr marL="0" indent="0">
               <a:lnSpc>
@@ -2007,6 +2058,7 @@
                 <a:spcPts val="0"/>
               </a:spcAft>
               <a:buNone/>
+              <a:defRPr/>
             </a:lvl7pPr>
             <a:lvl8pPr marL="0" indent="0">
               <a:lnSpc>
@@ -2019,6 +2071,7 @@
                 <a:spcPts val="0"/>
               </a:spcAft>
               <a:buNone/>
+              <a:defRPr/>
             </a:lvl8pPr>
             <a:lvl9pPr marL="0" indent="0">
               <a:lnSpc>
@@ -2031,6 +2084,7 @@
                 <a:spcPts val="0"/>
               </a:spcAft>
               <a:buNone/>
+              <a:defRPr/>
             </a:lvl9pPr>
           </a:lstStyle>
           <a:p xmlns:a="http://schemas.openxmlformats.org/drawingml/2006/main"/>
@@ -2082,6 +2136,7 @@
                 <a:spcPts val="1200"/>
               </a:spcAft>
               <a:buChar char="•"/>
+              <a:defRPr/>
             </a:lvl1pPr>
             <a:lvl2pPr marL="533400" indent="-228600">
               <a:lnSpc>
@@ -2094,6 +2149,7 @@
                 <a:spcPts val="1200"/>
               </a:spcAft>
               <a:buChar char="•"/>
+              <a:defRPr/>
             </a:lvl2pPr>
             <a:lvl3pPr marL="838200" indent="-228600">
               <a:lnSpc>
@@ -2106,6 +2162,7 @@
                 <a:spcPts val="1200"/>
               </a:spcAft>
               <a:buChar char="•"/>
+              <a:defRPr/>
             </a:lvl3pPr>
             <a:lvl4pPr marL="1143000" indent="-228600">
               <a:lnSpc>
@@ -2118,6 +2175,7 @@
                 <a:spcPts val="1200"/>
               </a:spcAft>
               <a:buChar char="•"/>
+              <a:defRPr/>
             </a:lvl4pPr>
             <a:lvl5pPr marL="1447800" indent="-228600">
               <a:lnSpc>
@@ -2130,6 +2188,7 @@
                 <a:spcPts val="1200"/>
               </a:spcAft>
               <a:buChar char="•"/>
+              <a:defRPr/>
             </a:lvl5pPr>
             <a:lvl6pPr marL="1752600" indent="-228600">
               <a:lnSpc>
@@ -2142,6 +2201,7 @@
                 <a:spcPts val="1200"/>
               </a:spcAft>
               <a:buChar char="•"/>
+              <a:defRPr/>
             </a:lvl6pPr>
             <a:lvl7pPr marL="2057400" indent="-228600">
               <a:lnSpc>
@@ -2154,6 +2214,7 @@
                 <a:spcPts val="1200"/>
               </a:spcAft>
               <a:buChar char="•"/>
+              <a:defRPr/>
             </a:lvl7pPr>
             <a:lvl8pPr marL="2362200" indent="-228600">
               <a:lnSpc>
@@ -2166,6 +2227,7 @@
                 <a:spcPts val="1200"/>
               </a:spcAft>
               <a:buChar char="•"/>
+              <a:defRPr/>
             </a:lvl8pPr>
             <a:lvl9pPr marL="2667000" indent="-228600">
               <a:lnSpc>
@@ -2178,6 +2240,7 @@
                 <a:spcPts val="1200"/>
               </a:spcAft>
               <a:buChar char="•"/>
+              <a:defRPr/>
             </a:lvl9pPr>
           </a:lstStyle>
           <a:p xmlns:a="http://schemas.openxmlformats.org/drawingml/2006/main"/>
@@ -2229,6 +2292,7 @@
                 <a:spcPts val="1200"/>
               </a:spcAft>
               <a:buChar char="•"/>
+              <a:defRPr/>
             </a:lvl1pPr>
             <a:lvl2pPr marL="533400" indent="-228600">
               <a:lnSpc>
@@ -2241,6 +2305,7 @@
                 <a:spcPts val="1200"/>
               </a:spcAft>
               <a:buChar char="•"/>
+              <a:defRPr/>
             </a:lvl2pPr>
             <a:lvl3pPr marL="838200" indent="-228600">
               <a:lnSpc>
@@ -2253,6 +2318,7 @@
                 <a:spcPts val="1200"/>
               </a:spcAft>
               <a:buChar char="•"/>
+              <a:defRPr/>
             </a:lvl3pPr>
             <a:lvl4pPr marL="1143000" indent="-228600">
               <a:lnSpc>
@@ -2265,6 +2331,7 @@
                 <a:spcPts val="1200"/>
               </a:spcAft>
               <a:buChar char="•"/>
+              <a:defRPr/>
             </a:lvl4pPr>
             <a:lvl5pPr marL="1447800" indent="-228600">
               <a:lnSpc>
@@ -2277,6 +2344,7 @@
                 <a:spcPts val="1200"/>
               </a:spcAft>
               <a:buChar char="•"/>
+              <a:defRPr/>
             </a:lvl5pPr>
             <a:lvl6pPr marL="1752600" indent="-228600">
               <a:lnSpc>
@@ -2289,6 +2357,7 @@
                 <a:spcPts val="1200"/>
               </a:spcAft>
               <a:buChar char="•"/>
+              <a:defRPr/>
             </a:lvl6pPr>
             <a:lvl7pPr marL="2057400" indent="-228600">
               <a:lnSpc>
@@ -2301,6 +2370,7 @@
                 <a:spcPts val="1200"/>
               </a:spcAft>
               <a:buChar char="•"/>
+              <a:defRPr/>
             </a:lvl7pPr>
             <a:lvl8pPr marL="2362200" indent="-228600">
               <a:lnSpc>
@@ -2313,6 +2383,7 @@
                 <a:spcPts val="1200"/>
               </a:spcAft>
               <a:buChar char="•"/>
+              <a:defRPr/>
             </a:lvl8pPr>
             <a:lvl9pPr marL="2667000" indent="-228600">
               <a:lnSpc>
@@ -2325,6 +2396,7 @@
                 <a:spcPts val="1200"/>
               </a:spcAft>
               <a:buChar char="•"/>
+              <a:defRPr/>
             </a:lvl9pPr>
           </a:lstStyle>
           <a:p xmlns:a="http://schemas.openxmlformats.org/drawingml/2006/main"/>
@@ -2424,6 +2496,7 @@
                 <a:spcPts val="0"/>
               </a:spcAft>
               <a:buNone/>
+              <a:defRPr/>
             </a:lvl1pPr>
             <a:lvl2pPr marL="0" indent="0">
               <a:lnSpc>
@@ -2436,6 +2509,7 @@
                 <a:spcPts val="0"/>
               </a:spcAft>
               <a:buNone/>
+              <a:defRPr/>
             </a:lvl2pPr>
             <a:lvl3pPr marL="0" indent="0">
               <a:lnSpc>
@@ -2448,6 +2522,7 @@
                 <a:spcPts val="0"/>
               </a:spcAft>
               <a:buNone/>
+              <a:defRPr/>
             </a:lvl3pPr>
             <a:lvl4pPr marL="0" indent="0">
               <a:lnSpc>
@@ -2460,6 +2535,7 @@
                 <a:spcPts val="0"/>
               </a:spcAft>
               <a:buNone/>
+              <a:defRPr/>
             </a:lvl4pPr>
             <a:lvl5pPr marL="0" indent="0">
               <a:lnSpc>
@@ -2472,6 +2548,7 @@
                 <a:spcPts val="0"/>
               </a:spcAft>
               <a:buNone/>
+              <a:defRPr/>
             </a:lvl5pPr>
             <a:lvl6pPr marL="0" indent="0">
               <a:lnSpc>
@@ -2484,6 +2561,7 @@
                 <a:spcPts val="0"/>
               </a:spcAft>
               <a:buNone/>
+              <a:defRPr/>
             </a:lvl6pPr>
             <a:lvl7pPr marL="0" indent="0">
               <a:lnSpc>
@@ -2496,6 +2574,7 @@
                 <a:spcPts val="0"/>
               </a:spcAft>
               <a:buNone/>
+              <a:defRPr/>
             </a:lvl7pPr>
             <a:lvl8pPr marL="0" indent="0">
               <a:lnSpc>
@@ -2508,6 +2587,7 @@
                 <a:spcPts val="0"/>
               </a:spcAft>
               <a:buNone/>
+              <a:defRPr/>
             </a:lvl8pPr>
             <a:lvl9pPr marL="0" indent="0">
               <a:lnSpc>
@@ -2520,6 +2600,7 @@
                 <a:spcPts val="0"/>
               </a:spcAft>
               <a:buNone/>
+              <a:defRPr/>
             </a:lvl9pPr>
           </a:lstStyle>
           <a:p xmlns:a="http://schemas.openxmlformats.org/drawingml/2006/main"/>
@@ -2571,6 +2652,7 @@
                 <a:spcPts val="1200"/>
               </a:spcAft>
               <a:buChar char="•"/>
+              <a:defRPr/>
             </a:lvl1pPr>
             <a:lvl2pPr marL="533400" indent="-228600">
               <a:lnSpc>
@@ -2583,6 +2665,7 @@
                 <a:spcPts val="1200"/>
               </a:spcAft>
               <a:buChar char="•"/>
+              <a:defRPr/>
             </a:lvl2pPr>
             <a:lvl3pPr marL="838200" indent="-228600">
               <a:lnSpc>
@@ -2595,6 +2678,7 @@
                 <a:spcPts val="1200"/>
               </a:spcAft>
               <a:buChar char="•"/>
+              <a:defRPr/>
             </a:lvl3pPr>
             <a:lvl4pPr marL="1143000" indent="-228600">
               <a:lnSpc>
@@ -2607,6 +2691,7 @@
                 <a:spcPts val="1200"/>
               </a:spcAft>
               <a:buChar char="•"/>
+              <a:defRPr/>
             </a:lvl4pPr>
             <a:lvl5pPr marL="1447800" indent="-228600">
               <a:lnSpc>
@@ -2619,6 +2704,7 @@
                 <a:spcPts val="1200"/>
               </a:spcAft>
               <a:buChar char="•"/>
+              <a:defRPr/>
             </a:lvl5pPr>
             <a:lvl6pPr marL="1752600" indent="-228600">
               <a:lnSpc>
@@ -2631,6 +2717,7 @@
                 <a:spcPts val="1200"/>
               </a:spcAft>
               <a:buChar char="•"/>
+              <a:defRPr/>
             </a:lvl6pPr>
             <a:lvl7pPr marL="2057400" indent="-228600">
               <a:lnSpc>
@@ -2643,6 +2730,7 @@
                 <a:spcPts val="1200"/>
               </a:spcAft>
               <a:buChar char="•"/>
+              <a:defRPr/>
             </a:lvl7pPr>
             <a:lvl8pPr marL="2362200" indent="-228600">
               <a:lnSpc>
@@ -2655,6 +2743,7 @@
                 <a:spcPts val="1200"/>
               </a:spcAft>
               <a:buChar char="•"/>
+              <a:defRPr/>
             </a:lvl8pPr>
             <a:lvl9pPr marL="2667000" indent="-228600">
               <a:lnSpc>
@@ -2667,6 +2756,7 @@
                 <a:spcPts val="1200"/>
               </a:spcAft>
               <a:buChar char="•"/>
+              <a:defRPr/>
             </a:lvl9pPr>
           </a:lstStyle>
           <a:p xmlns:a="http://schemas.openxmlformats.org/drawingml/2006/main"/>
@@ -2715,12 +2805,12 @@
   </p:cSld>
   <p:clrMap bg1="lt1" tx1="dk1" bg2="lt2" tx2="dk2" accent1="accent1" accent2="accent2" accent3="accent3" accent4="accent4" accent5="accent5" accent6="accent6" hlink="hlink" folHlink="folHlink"/>
   <p:sldLayoutIdLst>
-    <p:sldLayoutId xmlns:r="http://schemas.openxmlformats.org/officeDocument/2006/relationships" id="2147483649" r:id="R49cd110ac4b74168"/>
-    <p:sldLayoutId xmlns:r="http://schemas.openxmlformats.org/officeDocument/2006/relationships" id="2147483650" r:id="R81f78523d5c6463e"/>
-    <p:sldLayoutId xmlns:r="http://schemas.openxmlformats.org/officeDocument/2006/relationships" id="2147483651" r:id="R20de551b5432469d"/>
-    <p:sldLayoutId xmlns:r="http://schemas.openxmlformats.org/officeDocument/2006/relationships" id="2147483652" r:id="Rae0a9791a4a84968"/>
-    <p:sldLayoutId xmlns:r="http://schemas.openxmlformats.org/officeDocument/2006/relationships" id="2147483653" r:id="Re927fbe424f1471f"/>
-    <p:sldLayoutId xmlns:r="http://schemas.openxmlformats.org/officeDocument/2006/relationships" id="2147483654" r:id="Re03f2d6a78304828"/>
+    <p:sldLayoutId xmlns:r="http://schemas.openxmlformats.org/officeDocument/2006/relationships" id="2147483649" r:id="R62f1501039f74e06"/>
+    <p:sldLayoutId xmlns:r="http://schemas.openxmlformats.org/officeDocument/2006/relationships" id="2147483650" r:id="R1d19e856542e4125"/>
+    <p:sldLayoutId xmlns:r="http://schemas.openxmlformats.org/officeDocument/2006/relationships" id="2147483651" r:id="Rb55c44a29ee3472e"/>
+    <p:sldLayoutId xmlns:r="http://schemas.openxmlformats.org/officeDocument/2006/relationships" id="2147483652" r:id="R486314dfc0ba4e21"/>
+    <p:sldLayoutId xmlns:r="http://schemas.openxmlformats.org/officeDocument/2006/relationships" id="2147483653" r:id="R79de9b919bf04b7e"/>
+    <p:sldLayoutId xmlns:r="http://schemas.openxmlformats.org/officeDocument/2006/relationships" id="2147483654" r:id="R497c136dcf494688"/>
   </p:sldLayoutIdLst>
   <p:txStyles>
     <p:titleStyle>
@@ -3631,6 +3721,7 @@
           <a:lstStyle xmlns:a="http://schemas.openxmlformats.org/drawingml/2006/main"/>
           <a:p xmlns:a="http://schemas.openxmlformats.org/drawingml/2006/main">
             <a:pPr>
+              <a:buNone/>
               <a:defRPr sz="4500" b="1">
                 <a:solidFill>
                   <a:srgbClr val="203952"/>
@@ -3688,6 +3779,7 @@
           <a:lstStyle xmlns:a="http://schemas.openxmlformats.org/drawingml/2006/main"/>
           <a:p xmlns:a="http://schemas.openxmlformats.org/drawingml/2006/main">
             <a:pPr>
+              <a:buNone/>
               <a:defRPr sz="4200" b="1">
                 <a:solidFill>
                   <a:srgbClr val="182B43"/>
@@ -3711,6 +3803,7 @@
           </a:p>
           <a:p xmlns:a="http://schemas.openxmlformats.org/drawingml/2006/main">
             <a:pPr>
+              <a:buNone/>
               <a:defRPr sz="4200" b="1">
                 <a:solidFill>
                   <a:srgbClr val="182B43"/>
@@ -3768,6 +3861,7 @@
           <a:lstStyle xmlns:a="http://schemas.openxmlformats.org/drawingml/2006/main"/>
           <a:p xmlns:a="http://schemas.openxmlformats.org/drawingml/2006/main">
             <a:pPr>
+              <a:buNone/>
               <a:defRPr sz="2100" b="0">
                 <a:solidFill>
                   <a:srgbClr val="556578"/>
@@ -3825,6 +3919,7 @@
           <a:lstStyle xmlns:a="http://schemas.openxmlformats.org/drawingml/2006/main"/>
           <a:p xmlns:a="http://schemas.openxmlformats.org/drawingml/2006/main">
             <a:pPr>
+              <a:buNone/>
               <a:defRPr sz="1875" b="0">
                 <a:solidFill>
                   <a:srgbClr val="8D641E"/>
@@ -3848,6 +3943,7 @@
           </a:p>
           <a:p xmlns:a="http://schemas.openxmlformats.org/drawingml/2006/main">
             <a:pPr>
+              <a:buNone/>
               <a:defRPr sz="1875" b="0">
                 <a:solidFill>
                   <a:srgbClr val="8D641E"/>
@@ -3934,6 +4030,7 @@
           <a:lstStyle xmlns:a="http://schemas.openxmlformats.org/drawingml/2006/main"/>
           <a:p xmlns:a="http://schemas.openxmlformats.org/drawingml/2006/main">
             <a:pPr>
+              <a:buNone/>
               <a:defRPr sz="3150" b="1">
                 <a:solidFill>
                   <a:srgbClr val="203952"/>
@@ -3991,6 +4088,7 @@
           <a:lstStyle xmlns:a="http://schemas.openxmlformats.org/drawingml/2006/main"/>
           <a:p xmlns:a="http://schemas.openxmlformats.org/drawingml/2006/main">
             <a:pPr>
+              <a:buNone/>
               <a:defRPr sz="1275" b="0">
                 <a:solidFill>
                   <a:srgbClr val="556578"/>
@@ -4016,7 +4114,13 @@
       </p:sp>
       <p:graphicFrame>
         <p:nvGraphicFramePr>
-          <p:cNvPr id="9" name="Chart"/>
+          <p:cNvPr id="9" name="Chart">
+            <a:extLst xmlns:a="http://schemas.openxmlformats.org/drawingml/2006/main">
+              <a:ext uri="{FF2B5EF4-FFF2-40B4-BE49-F238E27FC236}">
+                <a16:creationId xmlns:a16="http://schemas.microsoft.com/office/drawing/2014/main" id="{A5C7941F-E700-4B98-9E35-56ABD73C81C1}"/>
+              </a:ext>
+            </a:extLst>
+          </p:cNvPr>
           <p:cNvGraphicFramePr/>
           <p:nvPr/>
         </p:nvGraphicFramePr>
@@ -4026,7 +4130,7 @@
         </p:xfrm>
         <a:graphic xmlns:a="http://schemas.openxmlformats.org/drawingml/2006/main">
           <a:graphicData uri="http://schemas.openxmlformats.org/drawingml/2006/chart">
-            <c:chart xmlns:r="http://schemas.openxmlformats.org/officeDocument/2006/relationships" xmlns:c="http://schemas.openxmlformats.org/drawingml/2006/chart" r:id="R0d6b34ebbe8149f6"/>
+            <c:chart xmlns:r="http://schemas.openxmlformats.org/officeDocument/2006/relationships" xmlns:c="http://schemas.openxmlformats.org/drawingml/2006/chart" r:id="Rd2f0cb2db3d64e19"/>
           </a:graphicData>
         </a:graphic>
       </p:graphicFrame>
@@ -4064,6 +4168,7 @@
           <a:lstStyle xmlns:a="http://schemas.openxmlformats.org/drawingml/2006/main"/>
           <a:p xmlns:a="http://schemas.openxmlformats.org/drawingml/2006/main">
             <a:pPr>
+              <a:buNone/>
               <a:defRPr sz="1650" b="0">
                 <a:solidFill>
                   <a:srgbClr val="556578"/>
@@ -4089,7 +4194,13 @@
       </p:sp>
       <p:graphicFrame>
         <p:nvGraphicFramePr>
-          <p:cNvPr id="11" name=""/>
+          <p:cNvPr id="11" name="">
+            <a:extLst xmlns:a="http://schemas.openxmlformats.org/drawingml/2006/main">
+              <a:ext uri="{FF2B5EF4-FFF2-40B4-BE49-F238E27FC236}">
+                <a16:creationId xmlns:a16="http://schemas.microsoft.com/office/drawing/2014/main" id="{08C7EE65-CDCA-4A7A-8579-1407462B3154}"/>
+              </a:ext>
+            </a:extLst>
+          </p:cNvPr>
           <p:cNvGraphicFramePr/>
           <p:nvPr/>
         </p:nvGraphicFramePr>
@@ -4343,6 +4454,7 @@
           <a:lstStyle xmlns:a="http://schemas.openxmlformats.org/drawingml/2006/main"/>
           <a:p xmlns:a="http://schemas.openxmlformats.org/drawingml/2006/main">
             <a:pPr>
+              <a:buNone/>
               <a:defRPr sz="1875" b="0">
                 <a:solidFill>
                   <a:srgbClr val="182B43"/>
@@ -4366,6 +4478,7 @@
           </a:p>
           <a:p xmlns:a="http://schemas.openxmlformats.org/drawingml/2006/main">
             <a:pPr>
+              <a:buNone/>
               <a:defRPr sz="1875" b="0">
                 <a:solidFill>
                   <a:srgbClr val="182B43"/>
@@ -4389,6 +4502,7 @@
           </a:p>
           <a:p xmlns:a="http://schemas.openxmlformats.org/drawingml/2006/main">
             <a:pPr>
+              <a:buNone/>
               <a:defRPr sz="1875" b="0">
                 <a:solidFill>
                   <a:srgbClr val="182B43"/>
@@ -4475,6 +4589,7 @@
           <a:lstStyle xmlns:a="http://schemas.openxmlformats.org/drawingml/2006/main"/>
           <a:p xmlns:a="http://schemas.openxmlformats.org/drawingml/2006/main">
             <a:pPr>
+              <a:buNone/>
               <a:defRPr sz="3150" b="1">
                 <a:solidFill>
                   <a:srgbClr val="203952"/>
@@ -4532,6 +4647,7 @@
           <a:lstStyle xmlns:a="http://schemas.openxmlformats.org/drawingml/2006/main"/>
           <a:p xmlns:a="http://schemas.openxmlformats.org/drawingml/2006/main">
             <a:pPr>
+              <a:buNone/>
               <a:defRPr sz="1275" b="0">
                 <a:solidFill>
                   <a:srgbClr val="556578"/>
@@ -4557,7 +4673,13 @@
       </p:sp>
       <p:graphicFrame>
         <p:nvGraphicFramePr>
-          <p:cNvPr id="8" name=""/>
+          <p:cNvPr id="8" name="">
+            <a:extLst xmlns:a="http://schemas.openxmlformats.org/drawingml/2006/main">
+              <a:ext uri="{FF2B5EF4-FFF2-40B4-BE49-F238E27FC236}">
+                <a16:creationId xmlns:a16="http://schemas.microsoft.com/office/drawing/2014/main" id="{F748CF46-43F1-4F0B-8021-19AB2D7E5D7F}"/>
+              </a:ext>
+            </a:extLst>
+          </p:cNvPr>
           <p:cNvGraphicFramePr/>
           <p:nvPr/>
         </p:nvGraphicFramePr>
@@ -5103,6 +5225,7 @@
           <a:lstStyle xmlns:a="http://schemas.openxmlformats.org/drawingml/2006/main"/>
           <a:p xmlns:a="http://schemas.openxmlformats.org/drawingml/2006/main">
             <a:pPr>
+              <a:buNone/>
               <a:defRPr sz="2100" b="1">
                 <a:solidFill>
                   <a:srgbClr val="203952"/>
@@ -5157,10 +5280,15 @@
           <a:bodyPr xmlns:a="http://schemas.openxmlformats.org/drawingml/2006/main">
             <a:noAutofit/>
           </a:bodyPr>
-          <a:lstStyle xmlns:a="http://schemas.openxmlformats.org/drawingml/2006/main"/>
+          <a:lstStyle xmlns:a="http://schemas.openxmlformats.org/drawingml/2006/main">
+            <a:defPPr>
+              <a:defRPr sz="1650"/>
+            </a:defPPr>
+          </a:lstStyle>
           <a:p xmlns:a="http://schemas.openxmlformats.org/drawingml/2006/main">
             <a:pPr>
-              <a:defRPr sz="1875" b="0">
+              <a:buNone/>
+              <a:defRPr sz="1650" b="0">
                 <a:solidFill>
                   <a:srgbClr val="182B43"/>
                 </a:solidFill>
@@ -5170,7 +5298,7 @@
               </a:defRPr>
             </a:pPr>
             <a:r>
-              <a:rPr sz="1875" b="0">
+              <a:rPr sz="1650" b="0">
                 <a:solidFill>
                   <a:srgbClr val="182B43"/>
                 </a:solidFill>
@@ -5178,12 +5306,13 @@
                 <a:ea typeface="Arial"/>
                 <a:cs typeface="Arial"/>
               </a:rPr>
-              <a:t>FY2025 exceptional gains and FY2026 investment gains affect reported profit.</a:t>
+              <a:t>FY2026 cash bridge: INR 423.60 crore from cash-flow activities + INR 112.98 crore from group changes</a:t>
             </a:r>
           </a:p>
           <a:p xmlns:a="http://schemas.openxmlformats.org/drawingml/2006/main">
             <a:pPr>
-              <a:defRPr sz="1875" b="0">
+              <a:buNone/>
+              <a:defRPr sz="1650" b="0">
                 <a:solidFill>
                   <a:srgbClr val="182B43"/>
                 </a:solidFill>
@@ -5193,7 +5322,7 @@
               </a:defRPr>
             </a:pPr>
             <a:r>
-              <a:rPr sz="1875" b="0">
+              <a:rPr sz="1650" b="0">
                 <a:solidFill>
                   <a:srgbClr val="182B43"/>
                 </a:solidFill>
@@ -5201,7 +5330,7 @@
                 <a:ea typeface="Arial"/>
                 <a:cs typeface="Arial"/>
               </a:rPr>
-              <a:t>Operating measures and the cash-flow statement provide necessary context.</a:t>
+              <a:t>= INR 536.58 crore increase in closing cash (Screener: INR 537 crore, rounded).</a:t>
             </a:r>
           </a:p>
         </p:txBody>
@@ -5269,6 +5398,7 @@
           <a:lstStyle xmlns:a="http://schemas.openxmlformats.org/drawingml/2006/main"/>
           <a:p xmlns:a="http://schemas.openxmlformats.org/drawingml/2006/main">
             <a:pPr>
+              <a:buNone/>
               <a:defRPr sz="3150" b="1">
                 <a:solidFill>
                   <a:srgbClr val="203952"/>
@@ -5326,6 +5456,7 @@
           <a:lstStyle xmlns:a="http://schemas.openxmlformats.org/drawingml/2006/main"/>
           <a:p xmlns:a="http://schemas.openxmlformats.org/drawingml/2006/main">
             <a:pPr>
+              <a:buNone/>
               <a:defRPr sz="1275" b="0">
                 <a:solidFill>
                   <a:srgbClr val="556578"/>
@@ -5351,7 +5482,13 @@
       </p:sp>
       <p:graphicFrame>
         <p:nvGraphicFramePr>
-          <p:cNvPr id="8" name="Chart"/>
+          <p:cNvPr id="8" name="Chart">
+            <a:extLst xmlns:a="http://schemas.openxmlformats.org/drawingml/2006/main">
+              <a:ext uri="{FF2B5EF4-FFF2-40B4-BE49-F238E27FC236}">
+                <a16:creationId xmlns:a16="http://schemas.microsoft.com/office/drawing/2014/main" id="{9641EE30-0361-4D24-A4CA-516C70DC7373}"/>
+              </a:ext>
+            </a:extLst>
+          </p:cNvPr>
           <p:cNvGraphicFramePr/>
           <p:nvPr/>
         </p:nvGraphicFramePr>
@@ -5361,7 +5498,7 @@
         </p:xfrm>
         <a:graphic xmlns:a="http://schemas.openxmlformats.org/drawingml/2006/main">
           <a:graphicData uri="http://schemas.openxmlformats.org/drawingml/2006/chart">
-            <c:chart xmlns:r="http://schemas.openxmlformats.org/officeDocument/2006/relationships" xmlns:c="http://schemas.openxmlformats.org/drawingml/2006/chart" r:id="R50346e77680b4418"/>
+            <c:chart xmlns:r="http://schemas.openxmlformats.org/officeDocument/2006/relationships" xmlns:c="http://schemas.openxmlformats.org/drawingml/2006/chart" r:id="Re64c088c603a4860"/>
           </a:graphicData>
         </a:graphic>
       </p:graphicFrame>
@@ -5399,6 +5536,7 @@
           <a:lstStyle xmlns:a="http://schemas.openxmlformats.org/drawingml/2006/main"/>
           <a:p xmlns:a="http://schemas.openxmlformats.org/drawingml/2006/main">
             <a:pPr>
+              <a:buNone/>
               <a:defRPr sz="1650" b="0">
                 <a:solidFill>
                   <a:srgbClr val="556578"/>
@@ -5456,6 +5594,7 @@
           <a:lstStyle xmlns:a="http://schemas.openxmlformats.org/drawingml/2006/main"/>
           <a:p xmlns:a="http://schemas.openxmlformats.org/drawingml/2006/main">
             <a:pPr>
+              <a:buNone/>
               <a:defRPr sz="2025" b="0">
                 <a:solidFill>
                   <a:srgbClr val="182B43"/>
@@ -5479,6 +5618,7 @@
           </a:p>
           <a:p xmlns:a="http://schemas.openxmlformats.org/drawingml/2006/main">
             <a:pPr>
+              <a:buNone/>
               <a:defRPr sz="2025" b="0">
                 <a:solidFill>
                   <a:srgbClr val="182B43"/>
@@ -5565,6 +5705,7 @@
           <a:lstStyle xmlns:a="http://schemas.openxmlformats.org/drawingml/2006/main"/>
           <a:p xmlns:a="http://schemas.openxmlformats.org/drawingml/2006/main">
             <a:pPr>
+              <a:buNone/>
               <a:defRPr sz="3150" b="1">
                 <a:solidFill>
                   <a:srgbClr val="203952"/>
@@ -5622,6 +5763,7 @@
           <a:lstStyle xmlns:a="http://schemas.openxmlformats.org/drawingml/2006/main"/>
           <a:p xmlns:a="http://schemas.openxmlformats.org/drawingml/2006/main">
             <a:pPr>
+              <a:buNone/>
               <a:defRPr sz="1275" b="0">
                 <a:solidFill>
                   <a:srgbClr val="556578"/>
@@ -5647,7 +5789,13 @@
       </p:sp>
       <p:graphicFrame>
         <p:nvGraphicFramePr>
-          <p:cNvPr id="8" name=""/>
+          <p:cNvPr id="8" name="">
+            <a:extLst xmlns:a="http://schemas.openxmlformats.org/drawingml/2006/main">
+              <a:ext uri="{FF2B5EF4-FFF2-40B4-BE49-F238E27FC236}">
+                <a16:creationId xmlns:a16="http://schemas.microsoft.com/office/drawing/2014/main" id="{E27CFF03-5267-4323-9D85-F505F93160A8}"/>
+              </a:ext>
+            </a:extLst>
+          </p:cNvPr>
           <p:cNvGraphicFramePr/>
           <p:nvPr/>
         </p:nvGraphicFramePr>
@@ -5969,7 +6117,13 @@
       </p:graphicFrame>
       <p:graphicFrame>
         <p:nvGraphicFramePr>
-          <p:cNvPr id="9" name=""/>
+          <p:cNvPr id="9" name="">
+            <a:extLst xmlns:a="http://schemas.openxmlformats.org/drawingml/2006/main">
+              <a:ext uri="{FF2B5EF4-FFF2-40B4-BE49-F238E27FC236}">
+                <a16:creationId xmlns:a16="http://schemas.microsoft.com/office/drawing/2014/main" id="{C0CB61C2-BFC7-48A1-9338-EFB6EE8961A7}"/>
+              </a:ext>
+            </a:extLst>
+          </p:cNvPr>
           <p:cNvGraphicFramePr/>
           <p:nvPr/>
         </p:nvGraphicFramePr>
@@ -6323,6 +6477,7 @@
           <a:lstStyle xmlns:a="http://schemas.openxmlformats.org/drawingml/2006/main"/>
           <a:p xmlns:a="http://schemas.openxmlformats.org/drawingml/2006/main">
             <a:pPr>
+              <a:buNone/>
               <a:defRPr sz="1950" b="0">
                 <a:solidFill>
                   <a:srgbClr val="182B43"/>
@@ -6346,6 +6501,7 @@
           </a:p>
           <a:p xmlns:a="http://schemas.openxmlformats.org/drawingml/2006/main">
             <a:pPr>
+              <a:buNone/>
               <a:defRPr sz="1950" b="0">
                 <a:solidFill>
                   <a:srgbClr val="182B43"/>
@@ -6432,6 +6588,7 @@
           <a:lstStyle xmlns:a="http://schemas.openxmlformats.org/drawingml/2006/main"/>
           <a:p xmlns:a="http://schemas.openxmlformats.org/drawingml/2006/main">
             <a:pPr>
+              <a:buNone/>
               <a:defRPr sz="3150" b="1">
                 <a:solidFill>
                   <a:srgbClr val="203952"/>
@@ -6489,6 +6646,7 @@
           <a:lstStyle xmlns:a="http://schemas.openxmlformats.org/drawingml/2006/main"/>
           <a:p xmlns:a="http://schemas.openxmlformats.org/drawingml/2006/main">
             <a:pPr>
+              <a:buNone/>
               <a:defRPr sz="1275" b="0">
                 <a:solidFill>
                   <a:srgbClr val="556578"/>
@@ -6514,7 +6672,13 @@
       </p:sp>
       <p:graphicFrame>
         <p:nvGraphicFramePr>
-          <p:cNvPr id="7" name=""/>
+          <p:cNvPr id="7" name="">
+            <a:extLst xmlns:a="http://schemas.openxmlformats.org/drawingml/2006/main">
+              <a:ext uri="{FF2B5EF4-FFF2-40B4-BE49-F238E27FC236}">
+                <a16:creationId xmlns:a16="http://schemas.microsoft.com/office/drawing/2014/main" id="{749697B9-1A45-43FE-BC32-496C00C08D46}"/>
+              </a:ext>
+            </a:extLst>
+          </p:cNvPr>
           <p:cNvGraphicFramePr/>
           <p:nvPr/>
         </p:nvGraphicFramePr>
@@ -6936,10 +7100,15 @@
           <a:bodyPr xmlns:a="http://schemas.openxmlformats.org/drawingml/2006/main">
             <a:noAutofit/>
           </a:bodyPr>
-          <a:lstStyle xmlns:a="http://schemas.openxmlformats.org/drawingml/2006/main"/>
+          <a:lstStyle xmlns:a="http://schemas.openxmlformats.org/drawingml/2006/main">
+            <a:defPPr>
+              <a:defRPr sz="2025"/>
+            </a:defPPr>
+          </a:lstStyle>
           <a:p xmlns:a="http://schemas.openxmlformats.org/drawingml/2006/main">
             <a:pPr>
-              <a:defRPr sz="2175" b="1">
+              <a:buNone/>
+              <a:defRPr sz="2025" b="1">
                 <a:solidFill>
                   <a:srgbClr val="203952"/>
                 </a:solidFill>
@@ -6949,7 +7118,7 @@
               </a:defRPr>
             </a:pPr>
             <a:r>
-              <a:rPr sz="2175" b="1">
+              <a:rPr sz="2025" b="1">
                 <a:solidFill>
                   <a:srgbClr val="203952"/>
                 </a:solidFill>
@@ -6957,7 +7126,7 @@
                 <a:ea typeface="Arial"/>
                 <a:cs typeface="Arial"/>
               </a:rPr>
-              <a:t>A conditional pilot is justified only after invoice-level and funding validation.</a:t>
+              <a:t>Pilot collections after validation; review collections, inventory and supplier terms weekly.</a:t>
             </a:r>
           </a:p>
         </p:txBody>

</xml_diff>